<commit_message>
docs: pitch deck — 10 slides, architecture as layer index
Restructured PITCH-DECK around the 5-pillar deep-dive: TL;DR (5 layers) →
Architecture (with 1-5 labels mapping to pillars) → Single API → On-chain
Guard → Off-chain Guard → AI Guard → Human Approve → Ask. Merged cold-open
into title, x402 demo into Single API, marketplace into AI Guard, roadmap
into Ask. Rebuilt PDF + PPTX.

Co-Authored-By: Claude Opus 4.7 (1M context) <noreply@anthropic.com>
</commit_message>
<xml_diff>
--- a/PITCH-DECK.pptx
+++ b/PITCH-DECK.pptx
@@ -15,10 +15,9 @@
     <p:sldId id="263" r:id="rId9"/>
     <p:sldId id="264" r:id="rId10"/>
     <p:sldId id="265" r:id="rId11"/>
-    <p:sldId id="266" r:id="rId12"/>
   </p:sldIdLst>
   <p:notesMasterIdLst>
-    <p:notesMasterId r:id="rId13"/>
+    <p:notesMasterId r:id="rId12"/>
   </p:notesMasterIdLst>
   <p:sldSz cx="12192000" cy="6858000"/>
   <p:notesSz cx="6858000" cy="12192000"/>
@@ -512,9 +511,11 @@
           <a:p>
             <a:r>
               <a:rPr lang="en-US" dirty="0"/>
-              <a:t>COLD OPEN, 15 SECONDS.
-Most agent platforms ask you to pick: hand them your keys, or hand a custodian your funds.
-Either way, you lose. We built the third option.</a:t>
+              <a:t>SLIDE 1, 25 SECONDS.
+Every AI agent on-chain today is one prompt injection away from a drained
+wallet. Today you pick: hand a custodian your funds, or hand the agent
+your keys. Either way you lose. AgentGuard is the third option — the
+secure payments SDK for AI agents. Stripe-grade DX, keys never leave the user.</a:t>
             </a:r>
             <a:endParaRPr lang="en-US" dirty="0"/>
           </a:p>
@@ -602,11 +603,14 @@
           <a:p>
             <a:r>
               <a:rPr lang="en-US" dirty="0"/>
-              <a:t>SLIDE 9, 20 SECONDS.
-Three next moves. MPP — Tempo's new payments protocol — our session-key
-architecture is already the right shape for it, MVP is half a day.
-Multi-chain rolls out as soon as 7702 + ZeroDev support stabilizes elsewhere.
-And premium providers — Lakera first — turn the platform into a revenue engine.</a:t>
+              <a:t>SLIDE 10, 30 SECONDS.
+Three next moves, all on the primitives we shipped this week. MPP — Tempo's
+new payments protocol — half-day MVP. Multi-chain rolls out as soon as 7702
++ ZeroDev support stabilizes elsewhere. And premium providers turn the
+platform into a revenue engine. We're applying to Privy, ZeroDev, Base, and
+OpenAI sponsor tracks — this product sits across all four. Repo and live
+demo are at this URL. We'd love follow-ups with anyone building agent infra.
+Thanks.</a:t>
             </a:r>
             <a:endParaRPr lang="en-US" dirty="0"/>
           </a:p>
@@ -630,97 +634,6 @@
             <a:fld id="{F7021451-1387-4CA6-816F-3879F97B5CBC}" type="slidenum">
               <a:rPr lang="en-US"/>
               <a:t>10</a:t>
-            </a:fld>
-            <a:endParaRPr lang="en-US"/>
-          </a:p>
-        </p:txBody>
-      </p:sp>
-    </p:spTree>
-    <p:extLst>
-      <p:ext uri="{BB962C8B-B14F-4D97-AF65-F5344CB8AC3E}">
-        <p14:creationId xmlns:p14="http://schemas.microsoft.com/office/powerpoint/2010/main" val="1024086991"/>
-      </p:ext>
-    </p:extLst>
-  </p:cSld>
-  <p:clrMapOvr>
-    <a:masterClrMapping/>
-  </p:clrMapOvr>
-</p:notes>
-</file>
-
-<file path=ppt/notesSlides/notesSlide11.xml><?xml version="1.0" encoding="utf-8"?>
-<p:notes xmlns:a="http://schemas.openxmlformats.org/drawingml/2006/main" xmlns:r="http://schemas.openxmlformats.org/officeDocument/2006/relationships" xmlns:p="http://schemas.openxmlformats.org/presentationml/2006/main">
-  <p:cSld>
-    <p:spTree>
-      <p:nvGrpSpPr>
-        <p:cNvPr id="1" name=""/>
-        <p:cNvGrpSpPr/>
-        <p:nvPr/>
-      </p:nvGrpSpPr>
-      <p:grpSpPr>
-        <a:xfrm>
-          <a:off x="0" y="0"/>
-          <a:ext cx="0" cy="0"/>
-          <a:chOff x="0" y="0"/>
-          <a:chExt cx="0" cy="0"/>
-        </a:xfrm>
-      </p:grpSpPr>
-      <p:sp>
-        <p:nvSpPr>
-          <p:cNvPr id="2" name="Slide Image Placeholder 1"/>
-          <p:cNvSpPr>
-            <a:spLocks noGrp="1" noRot="1" noChangeAspect="1"/>
-          </p:cNvSpPr>
-          <p:nvPr>
-            <p:ph type="sldImg"/>
-          </p:nvPr>
-        </p:nvSpPr>
-        <p:spPr/>
-      </p:sp>
-      <p:sp>
-        <p:nvSpPr>
-          <p:cNvPr id="3" name="Notes Placeholder 2"/>
-          <p:cNvSpPr>
-            <a:spLocks noGrp="1"/>
-          </p:cNvSpPr>
-          <p:nvPr>
-            <p:ph type="body" idx="1"/>
-          </p:nvPr>
-        </p:nvSpPr>
-        <p:spPr/>
-        <p:txBody>
-          <a:bodyPr/>
-          <a:lstStyle/>
-          <a:p>
-            <a:r>
-              <a:rPr lang="en-US" dirty="0"/>
-              <a:t>SLIDE 10, 20 SECONDS.
-The ask. We're applying to Privy, ZeroDev, Base, and OpenAI sponsor tracks —
-this product sits across all four. We'd love follow-ups with anyone building
-agent infra; we think we're the missing layer. Repo and demo are live. Thanks.</a:t>
-            </a:r>
-            <a:endParaRPr lang="en-US" dirty="0"/>
-          </a:p>
-        </p:txBody>
-      </p:sp>
-      <p:sp>
-        <p:nvSpPr>
-          <p:cNvPr id="4" name="Slide Number Placeholder 3"/>
-          <p:cNvSpPr>
-            <a:spLocks noGrp="1"/>
-          </p:cNvSpPr>
-          <p:nvPr>
-            <p:ph type="sldNum" sz="quarter" idx="10"/>
-          </p:nvPr>
-        </p:nvSpPr>
-        <p:spPr/>
-        <p:txBody>
-          <a:bodyPr/>
-          <a:lstStyle/>
-          <a:p>
-            <a:fld id="{F7021451-1387-4CA6-816F-3879F97B5CBC}" type="slidenum">
-              <a:rPr lang="en-US"/>
-              <a:t>11</a:t>
             </a:fld>
             <a:endParaRPr lang="en-US"/>
           </a:p>
@@ -785,10 +698,11 @@
           <a:p>
             <a:r>
               <a:rPr lang="en-US" dirty="0"/>
-              <a:t>SLIDE 1, 15 SECONDS.
-AgentGuard is the secure payments and action SDK for AI agents.
-Same DX as Stripe, but the keys never leave the user.
-Let me show you what's broken first.</a:t>
+              <a:t>SLIDE 2, 20 SECONDS.
+Coinbase CDP, Crossmint — fully custodial. They hold your keys.
+Or you go raw EOA, one private key in an env var, and the first malicious
+prompt empties the account. No one has solved the middle: agents that act
+autonomously without anyone holding ultimate authority over the funds.</a:t>
             </a:r>
             <a:endParaRPr lang="en-US" dirty="0"/>
           </a:p>
@@ -876,11 +790,12 @@
           <a:p>
             <a:r>
               <a:rPr lang="en-US" dirty="0"/>
-              <a:t>SLIDE 2, 20 SECONDS.
-Coinbase CDP, Crossmint — fully custodial. They hold your keys.
-Or you go raw EOA, one private key in an env var, and the first malicious
-prompt empties the account. No one has solved the middle: agents that act
-autonomously without anyone holding ultimate authority over the funds.</a:t>
+              <a:t>SLIDE 3, 20 SECONDS.
+Five things. One — single API, one line. Two — on-chain guard, the EVM
+enforces the cap, not us. Three — off-chain policy engine. Four — AI guard
+for the threats only agents face. Five — human approval for anything
+anomalous. The unifying theme: one config object, every knob configurable,
+and the defaults are safe.</a:t>
             </a:r>
             <a:endParaRPr lang="en-US" dirty="0"/>
           </a:p>
@@ -968,11 +883,15 @@
           <a:p>
             <a:r>
               <a:rPr lang="en-US" dirty="0"/>
-              <a:t>SLIDE 3, 20 SECONDS.
-Three layers. The hard guarantee is on-chain — the session key literally
-cannot exceed its cap. The policy engine handles recipient whitelists and
-rate limits. And the AI layer catches the specifically-agent threats:
-prompt injection, intent mismatch.</a:t>
+              <a:t>SLIDE 4, 30 SECONDS.
+Here's where those five layers physically live. The SDK at the top —
+that's the single API. Inside the backend, the policy engine is the
+off-chain guard, AI detect is the AI guard. Below the bundler, the smart
+account has three validators: the owner key — that's how Human Approve
+signs — and two session keys, which is what makes the on-chain guard
+EVM-enforced. Privy for identity, EIP-7702 to upgrade the EOA in place,
+ZeroDev Kernel for the validator modules. The next five slides are just
+zoom-ins on each numbered box.</a:t>
             </a:r>
             <a:endParaRPr lang="en-US" dirty="0"/>
           </a:p>
@@ -1060,12 +979,14 @@
           <a:p>
             <a:r>
               <a:rPr lang="en-US" dirty="0"/>
-              <a:t>SLIDE 4, 25 SECONDS.
-The stack: Privy for identity, EIP-7702 to upgrade the EOA in-place,
-ZeroDev Kernel for the validator modules, ZeroDev's v3 bundler + paymaster.
-Three validators on the account: the user's owner key, an agent session key
-with hard on-chain caps, and a guard session key the backend uses.
-The backend never sees the owner key.</a:t>
+              <a:t>SLIDE 5, 30 SECONDS.
+The developer writes this. One construct, one fetch. No key handling,
+no tier branching, no bundler config. The agent calls a paywalled endpoint,
+server returns 402, SDK signs with the session key, retries with X-PAYMENT,
+gets the data. Three calls in a row settle on Base Sepolia in about four
+seconds each. And the on-chain cap means even if the agent goes rogue
+it can spend at most ten dollars a day. Everything on the next four slides
+is opt-in configuration on this same object.</a:t>
             </a:r>
             <a:endParaRPr lang="en-US" dirty="0"/>
           </a:p>
@@ -1153,11 +1074,12 @@
           <a:p>
             <a:r>
               <a:rPr lang="en-US" dirty="0"/>
-              <a:t>SLIDE 5, 20 SECONDS.
-Three tiers. Under a dollar, agent signs itself — fast path for x402
-and API micropayments. Standard ops go through the policy engine and the
-guard signs. Anything large, anomalous, or AI-flagged escalates to the owner,
-who taps approve in Privy. One SDK call covers all three.</a:t>
+              <a:t>SLIDE 6, 20 SECONDS.
+This is the hard guarantee. The cap lives on-chain as a validator module
+on the smart account. Not a backend check, not a policy, an EVM rule.
+If our entire infrastructure is compromised, the worst case is still
+bounded by the cap. Ten dollars a day is the demo default. Production
+users tune it down.</a:t>
             </a:r>
             <a:endParaRPr lang="en-US" dirty="0"/>
           </a:p>
@@ -1245,12 +1167,11 @@
           <a:p>
             <a:r>
               <a:rPr lang="en-US" dirty="0"/>
-              <a:t>SLIDE 6, 25 SECONDS.
-The attack: someone slips a prompt-injection payload into the agent's input.
-The agent dutifully tries to drain to the attacker. Our intent-diff provider
-compares what the user actually asked for against what the agent is signing.
-Mismatch. Injection signature provider flags the classic 'ignore previous'
-pattern. Verdict hostile, tx blocked, owner notified.</a:t>
+              <a:t>SLIDE 7, 20 SECONDS.
+On-chain limits are bounded but coarse. The off-chain layer adds the
+nuance — a recipient whitelist, a rate limit so the agent can't burn its
+daily cap in two seconds, a slippage guard for x402 paywalls.
+Plain TypeScript, hot-reloadable, no contract redeploy.</a:t>
             </a:r>
             <a:endParaRPr lang="en-US" dirty="0"/>
           </a:p>
@@ -1338,13 +1259,16 @@
           <a:p>
             <a:r>
               <a:rPr lang="en-US" dirty="0"/>
-              <a:t>SLIDE 7, 25 SECONDS.
-The fast path. Agent fetches a paywalled endpoint, server returns 402,
-SDK reads the payment requirement, signs with the session key, retries,
-gets the data. Developer wrote one line. Three calls in a row, all settle
-on Base Sepolia in about four seconds each, no human in the loop,
-no backend approval — and the on-chain cap means even if the agent goes
-rogue it can spend at most ten dollars a day.</a:t>
+              <a:t>SLIDE 8, 30 SECONDS.
+This is the layer that doesn't exist for normal wallets. A user types a
+question, an attacker has slipped a payload into the data the agent reads.
+The agent dutifully signs a drain. Our intent-diff provider compares what
+the user actually asked against what the agent is signing. Mismatch,
+verdict hostile, escalates to human, zero wei moved. And the provider
+interface is pluggable. We ship two providers today. Post-hackathon,
+Lakera, Protect AI, Rebuff plug in, developer toggles them on, we take a
+margin. Network effects: every new provider makes every existing developer
+safer. Marketplace, not a point tool.</a:t>
             </a:r>
             <a:endParaRPr lang="en-US" dirty="0"/>
           </a:p>
@@ -1432,12 +1356,12 @@
           <a:p>
             <a:r>
               <a:rPr lang="en-US" dirty="0"/>
-              <a:t>SLIDE 8, 20 SECONDS.
-AI Detect is a pluggable provider interface. We ship two built-in providers today.
-Post-hackathon, the play is to be the integration layer — Lakera, Protect AI, Rebuff
-plug in, developer toggles them on, we take a margin on the call.
-Network effects: every new provider makes every existing developer safer.
-Marketplace, not a point tool.</a:t>
+              <a:t>SLIDE 9, 20 SECONDS.
+The owner only sees a push when something genuinely needs them — over the
+cap, off the whitelist, or AI-flagged. They tap approve inside Privy,
+the owner key signs inside the TEE, the userop goes out. The backend
+never sees the key. And the default is fail-closed — if the owner is
+asleep, the transaction is rejected, not waved through.</a:t>
             </a:r>
             <a:endParaRPr lang="en-US" dirty="0"/>
           </a:p>
@@ -1828,45 +1752,6 @@
 <file path=ppt/slides/slide10.xml><?xml version="1.0" encoding="utf-8"?>
 <p:sld xmlns:a="http://schemas.openxmlformats.org/drawingml/2006/main" xmlns:r="http://schemas.openxmlformats.org/officeDocument/2006/relationships" xmlns:p="http://schemas.openxmlformats.org/presentationml/2006/main">
   <p:cSld name="Slide 10">
-    <p:bg>
-      <p:bgPr>
-        <a:blipFill dpi="0" rotWithShape="1">
-          <a:blip r:embed="rId1">
-            <a:lum/>
-          </a:blip>
-          <a:srcRect/>
-          <a:stretch>
-            <a:fillRect/>
-          </a:stretch>
-        </a:blipFill>
-        <a:effectLst/>
-      </p:bgPr>
-    </p:bg>
-    <p:spTree>
-      <p:nvGrpSpPr>
-        <p:cNvPr id="1" name=""/>
-        <p:cNvGrpSpPr/>
-        <p:nvPr/>
-      </p:nvGrpSpPr>
-      <p:grpSpPr>
-        <a:xfrm>
-          <a:off x="0" y="0"/>
-          <a:ext cx="0" cy="0"/>
-          <a:chOff x="0" y="0"/>
-          <a:chExt cx="0" cy="0"/>
-        </a:xfrm>
-      </p:grpSpPr>
-    </p:spTree>
-  </p:cSld>
-  <p:clrMapOvr>
-    <a:masterClrMapping/>
-  </p:clrMapOvr>
-</p:sld>
-</file>
-
-<file path=ppt/slides/slide11.xml><?xml version="1.0" encoding="utf-8"?>
-<p:sld xmlns:a="http://schemas.openxmlformats.org/drawingml/2006/main" xmlns:r="http://schemas.openxmlformats.org/officeDocument/2006/relationships" xmlns:p="http://schemas.openxmlformats.org/presentationml/2006/main">
-  <p:cSld name="Slide 11">
     <p:bg>
       <p:bgPr>
         <a:blipFill dpi="0" rotWithShape="1">

</xml_diff>